<commit_message>
Translate full presentation to English
</commit_message>
<xml_diff>
--- a/SE_Process_AsIs_ToBe.pptx
+++ b/SE_Process_AsIs_ToBe.pptx
@@ -3407,7 +3407,7 @@
                 </a:solidFill>
                 <a:latin typeface="Titillium Web"/>
               </a:rPr>
-              <a:t>Redesenhando a Esteira de Pré-Venda</a:t>
+              <a:t>Redesigning the Pre-Sales Process</a:t>
             </a:r>
           </a:p>
         </p:txBody>
@@ -3522,7 +3522,7 @@
               </a:rPr>
               <a:t>Sales Eng
 +
-Implementação</a:t>
+Implementation</a:t>
             </a:r>
           </a:p>
         </p:txBody>
@@ -3679,7 +3679,7 @@
                 </a:solidFill>
                 <a:latin typeface="Titillium Web"/>
               </a:rPr>
-              <a:t>Abril 2026</a:t>
+              <a:t>April 2026</a:t>
             </a:r>
           </a:p>
         </p:txBody>
@@ -3853,7 +3853,7 @@
                 </a:solidFill>
                 <a:latin typeface="Titillium Web"/>
               </a:rPr>
-              <a:t>O PAPEL DO SOLUTIONS ENGINEER</a:t>
+              <a:t>THE ROLE OF THE SOLUTIONS ENGINEER</a:t>
             </a:r>
           </a:p>
         </p:txBody>
@@ -3888,7 +3888,7 @@
                 </a:solidFill>
                 <a:latin typeface="Titillium Web"/>
               </a:rPr>
-              <a:t>Um cargo. Ciclo completo.</a:t>
+              <a:t>One role. Full cycle.</a:t>
             </a:r>
           </a:p>
         </p:txBody>
@@ -4089,7 +4089,7 @@
                 </a:solidFill>
                 <a:latin typeface="Titillium Web"/>
               </a:rPr>
-              <a:t>• Pre-sales: demos e technical discovery</a:t>
+              <a:t>• Pre-sales: demos and technical discovery</a:t>
             </a:r>
           </a:p>
         </p:txBody>
@@ -4124,7 +4124,7 @@
                 </a:solidFill>
                 <a:latin typeface="Titillium Web"/>
               </a:rPr>
-              <a:t>• Suporte comercial ao BDM</a:t>
+              <a:t>• Commercial support to the BDM</a:t>
             </a:r>
           </a:p>
         </p:txBody>
@@ -4159,7 +4159,7 @@
                 </a:solidFill>
                 <a:latin typeface="Titillium Web"/>
               </a:rPr>
-              <a:t>• Sem envolvimento pós-contrato</a:t>
+              <a:t>• No post-contract involvement</a:t>
             </a:r>
           </a:p>
         </p:txBody>
@@ -4317,7 +4317,7 @@
                 </a:solidFill>
                 <a:latin typeface="Titillium Web"/>
               </a:rPr>
-              <a:t>Implementação</a:t>
+              <a:t>Implementation</a:t>
             </a:r>
           </a:p>
         </p:txBody>
@@ -4352,7 +4352,7 @@
                 </a:solidFill>
                 <a:latin typeface="Titillium Web"/>
               </a:rPr>
-              <a:t>• Onboarding técnico pós-contrato</a:t>
+              <a:t>• Technical onboarding post-contract</a:t>
             </a:r>
           </a:p>
         </p:txBody>
@@ -4387,7 +4387,7 @@
                 </a:solidFill>
                 <a:latin typeface="Titillium Web"/>
               </a:rPr>
-              <a:t>• Integração SDK/API com o merchant</a:t>
+              <a:t>• SDK/API integration with the merchant</a:t>
             </a:r>
           </a:p>
         </p:txBody>
@@ -4422,7 +4422,7 @@
                 </a:solidFill>
                 <a:latin typeface="Titillium Web"/>
               </a:rPr>
-              <a:t>• Sem visibilidade do ciclo comercial</a:t>
+              <a:t>• No visibility into the sales cycle</a:t>
             </a:r>
           </a:p>
         </p:txBody>
@@ -4570,7 +4570,7 @@
                 </a:solidFill>
                 <a:latin typeface="Titillium Web"/>
               </a:rPr>
-              <a:t>• Ciclo completo: pre-sales → go-live</a:t>
+              <a:t>• Full cycle: pre-sales → go-live</a:t>
             </a:r>
           </a:p>
         </p:txBody>
@@ -4605,7 +4605,7 @@
                 </a:solidFill>
                 <a:latin typeface="Titillium Web"/>
               </a:rPr>
-              <a:t>• Dono da demo e da integração técnica</a:t>
+              <a:t>• Owner of the demo and technical integration</a:t>
             </a:r>
           </a:p>
         </p:txBody>
@@ -4640,7 +4640,7 @@
                 </a:solidFill>
                 <a:latin typeface="Titillium Web"/>
               </a:rPr>
-              <a:t>• Referência técnica durante o deal</a:t>
+              <a:t>• Technical reference throughout the deal</a:t>
             </a:r>
           </a:p>
         </p:txBody>
@@ -4675,7 +4675,7 @@
                 </a:solidFill>
                 <a:latin typeface="Titillium Web"/>
               </a:rPr>
-              <a:t>Responsabilidades</a:t>
+              <a:t>Responsibilities</a:t>
             </a:r>
           </a:p>
         </p:txBody>
@@ -4841,7 +4841,7 @@
                 </a:solidFill>
                 <a:latin typeface="Titillium Web"/>
               </a:rPr>
-              <a:t>PRÉ-VENDA</a:t>
+              <a:t>PRE-SALES</a:t>
             </a:r>
           </a:p>
         </p:txBody>
@@ -4876,7 +4876,7 @@
                 </a:solidFill>
                 <a:latin typeface="Titillium Web"/>
               </a:rPr>
-              <a:t>• Qualificar fit técnico do merchant</a:t>
+              <a:t>• Qualify technical fit of the merchant</a:t>
             </a:r>
           </a:p>
         </p:txBody>
@@ -4911,7 +4911,7 @@
                 </a:solidFill>
                 <a:latin typeface="Titillium Web"/>
               </a:rPr>
-              <a:t>• Liderar technical discovery</a:t>
+              <a:t>• Lead technical discovery</a:t>
             </a:r>
           </a:p>
         </p:txBody>
@@ -4946,7 +4946,7 @@
                 </a:solidFill>
                 <a:latin typeface="Titillium Web"/>
               </a:rPr>
-              <a:t>• Demo personalizada — padrão Cinépolis</a:t>
+              <a:t>• Personalized demo — Cinépolis standard</a:t>
             </a:r>
           </a:p>
         </p:txBody>
@@ -4981,7 +4981,7 @@
                 </a:solidFill>
                 <a:latin typeface="Titillium Web"/>
               </a:rPr>
-              <a:t>• Responder RFPs e questões técnicas</a:t>
+              <a:t>• Answer RFPs and technical questions</a:t>
             </a:r>
           </a:p>
         </p:txBody>
@@ -5104,7 +5104,7 @@
                 </a:solidFill>
                 <a:latin typeface="Titillium Web"/>
               </a:rPr>
-              <a:t>FECHAMENTO</a:t>
+              <a:t>DEAL CLOSING</a:t>
             </a:r>
           </a:p>
         </p:txBody>
@@ -5139,7 +5139,7 @@
                 </a:solidFill>
                 <a:latin typeface="Titillium Web"/>
               </a:rPr>
-              <a:t>• Technical Scoping com time técnico</a:t>
+              <a:t>• Technical Scoping with tech team</a:t>
             </a:r>
           </a:p>
         </p:txBody>
@@ -5174,7 +5174,7 @@
                 </a:solidFill>
                 <a:latin typeface="Titillium Web"/>
               </a:rPr>
-              <a:t>• Definir arquitetura da solução</a:t>
+              <a:t>• Define solution architecture</a:t>
             </a:r>
           </a:p>
         </p:txBody>
@@ -5209,7 +5209,7 @@
                 </a:solidFill>
                 <a:latin typeface="Titillium Web"/>
               </a:rPr>
-              <a:t>• Apoiar negociação com input técnico</a:t>
+              <a:t>• Support negotiation with technical input</a:t>
             </a:r>
           </a:p>
         </p:txBody>
@@ -5244,7 +5244,7 @@
                 </a:solidFill>
                 <a:latin typeface="Titillium Web"/>
               </a:rPr>
-              <a:t>• Handoff ou execução da implementação</a:t>
+              <a:t>• Handoff or execute implementation</a:t>
             </a:r>
           </a:p>
         </p:txBody>
@@ -5367,7 +5367,7 @@
                 </a:solidFill>
                 <a:latin typeface="Titillium Web"/>
               </a:rPr>
-              <a:t>PÓS-CONTRATO</a:t>
+              <a:t>POST-CONTRACT</a:t>
             </a:r>
           </a:p>
         </p:txBody>
@@ -5402,7 +5402,7 @@
                 </a:solidFill>
                 <a:latin typeface="Titillium Web"/>
               </a:rPr>
-              <a:t>• Liderar onboarding técnico</a:t>
+              <a:t>• Lead technical onboarding</a:t>
             </a:r>
           </a:p>
         </p:txBody>
@@ -5437,7 +5437,7 @@
                 </a:solidFill>
                 <a:latin typeface="Titillium Web"/>
               </a:rPr>
-              <a:t>• Integrar SDK/API no ambiente do merchant</a:t>
+              <a:t>• Integrate SDK/API into merchant environment</a:t>
             </a:r>
           </a:p>
         </p:txBody>
@@ -5472,7 +5472,7 @@
                 </a:solidFill>
                 <a:latin typeface="Titillium Web"/>
               </a:rPr>
-              <a:t>• Suporte go-live e primeiros 90 dias</a:t>
+              <a:t>• Go-live support and first 90 days</a:t>
             </a:r>
           </a:p>
         </p:txBody>
@@ -5507,7 +5507,7 @@
                 </a:solidFill>
                 <a:latin typeface="Titillium Web"/>
               </a:rPr>
-              <a:t>• Identificar upsell com time comercial</a:t>
+              <a:t>• Identify upsell with commercial team</a:t>
             </a:r>
           </a:p>
         </p:txBody>
@@ -5681,7 +5681,7 @@
                 </a:solidFill>
                 <a:latin typeface="Titillium Web"/>
               </a:rPr>
-              <a:t>PRÓXIMOS PASSOS</a:t>
+              <a:t>NEXT STEPS</a:t>
             </a:r>
           </a:p>
         </p:txBody>
@@ -5716,7 +5716,7 @@
                 </a:solidFill>
                 <a:latin typeface="Titillium Web"/>
               </a:rPr>
-              <a:t>Como colocamos isso em prática.</a:t>
+              <a:t>How we put this into practice.</a:t>
             </a:r>
           </a:p>
         </p:txBody>
@@ -5872,7 +5872,7 @@
                 </a:solidFill>
                 <a:latin typeface="Titillium Web"/>
               </a:rPr>
-              <a:t>Sem. 1–2</a:t>
+              <a:t>Wk. 1–2</a:t>
             </a:r>
           </a:p>
         </p:txBody>
@@ -5907,7 +5907,7 @@
                 </a:solidFill>
                 <a:latin typeface="Titillium Web"/>
               </a:rPr>
-              <a:t>Definir critérios de acionamento</a:t>
+              <a:t>Define SE engagement criteria</a:t>
             </a:r>
           </a:p>
         </p:txBody>
@@ -5942,7 +5942,7 @@
                 </a:solidFill>
                 <a:latin typeface="Titillium Web"/>
               </a:rPr>
-              <a:t>Workshop Sales Leads + SE Leads. Thresholds de $, tier, strategic. Publicar.</a:t>
+              <a:t>Workshop with Sales Leads + SE Leads. Define $ thresholds, tier, strategic flags. Publish.</a:t>
             </a:r>
           </a:p>
         </p:txBody>
@@ -6098,7 +6098,7 @@
                 </a:solidFill>
                 <a:latin typeface="Titillium Web"/>
               </a:rPr>
-              <a:t>Sem. 2–3</a:t>
+              <a:t>Wk. 2–3</a:t>
             </a:r>
           </a:p>
         </p:txBody>
@@ -6133,7 +6133,7 @@
                 </a:solidFill>
                 <a:latin typeface="Titillium Web"/>
               </a:rPr>
-              <a:t>Criar template de Discovery</a:t>
+              <a:t>Create Discovery template</a:t>
             </a:r>
           </a:p>
         </p:txBody>
@@ -6168,7 +6168,7 @@
                 </a:solidFill>
                 <a:latin typeface="Titillium Web"/>
               </a:rPr>
-              <a:t>SE + BDM co-criam o documento. Testar com 2–3 deals em andamento.</a:t>
+              <a:t>SE + BDM co-create the document. Test with 2–3 live deals.</a:t>
             </a:r>
           </a:p>
         </p:txBody>
@@ -6324,7 +6324,7 @@
                 </a:solidFill>
                 <a:latin typeface="Titillium Web"/>
               </a:rPr>
-              <a:t>Sem. 3–4</a:t>
+              <a:t>Wk. 3–4</a:t>
             </a:r>
           </a:p>
         </p:txBody>
@@ -6359,7 +6359,7 @@
                 </a:solidFill>
                 <a:latin typeface="Titillium Web"/>
               </a:rPr>
-              <a:t>Configurar fluxo de ticket</a:t>
+              <a:t>Set up ticket workflow</a:t>
             </a:r>
           </a:p>
         </p:txBody>
@@ -6394,7 +6394,7 @@
                 </a:solidFill>
                 <a:latin typeface="Titillium Web"/>
               </a:rPr>
-              <a:t>Canal, form de request, SLA de 48h. Integrar com ferramenta de gestão.</a:t>
+              <a:t>Channel, request form, 48h SLA. Integrate with management tool.</a:t>
             </a:r>
           </a:p>
         </p:txBody>
@@ -6550,7 +6550,7 @@
                 </a:solidFill>
                 <a:latin typeface="Titillium Web"/>
               </a:rPr>
-              <a:t>Mês 2</a:t>
+              <a:t>Month 2</a:t>
             </a:r>
           </a:p>
         </p:txBody>
@@ -6585,7 +6585,7 @@
                 </a:solidFill>
                 <a:latin typeface="Titillium Web"/>
               </a:rPr>
-              <a:t>Enablement: demo padrão Cinépolis</a:t>
+              <a:t>Enablement: Cinépolis demo standard</a:t>
             </a:r>
           </a:p>
         </p:txBody>
@@ -6620,7 +6620,7 @@
                 </a:solidFill>
                 <a:latin typeface="Titillium Web"/>
               </a:rPr>
-              <a:t>Documentar e rodar sessão de enablement para todos os SEs.</a:t>
+              <a:t>Document and run enablement session for all SEs.</a:t>
             </a:r>
           </a:p>
         </p:txBody>
@@ -6776,7 +6776,7 @@
                 </a:solidFill>
                 <a:latin typeface="Titillium Web"/>
               </a:rPr>
-              <a:t>Mês 2–3</a:t>
+              <a:t>Month 2–3</a:t>
             </a:r>
           </a:p>
         </p:txBody>
@@ -6811,7 +6811,7 @@
                 </a:solidFill>
                 <a:latin typeface="Titillium Web"/>
               </a:rPr>
-              <a:t>Piloto com 5 deals + retrospectiva</a:t>
+              <a:t>Pilot with 5 deals + retrospective</a:t>
             </a:r>
           </a:p>
         </p:txBody>
@@ -6846,7 +6846,7 @@
                 </a:solidFill>
                 <a:latin typeface="Titillium Web"/>
               </a:rPr>
-              <a:t>Aplicar em 5 deals reais. Coletar feedback. Iterar e publicar v2.</a:t>
+              <a:t>Run with 5 real deals. Collect feedback. Iterate and publish v2.</a:t>
             </a:r>
           </a:p>
         </p:txBody>
@@ -7063,8 +7063,8 @@
                 </a:solidFill>
                 <a:latin typeface="Titillium Web"/>
               </a:rPr>
-              <a:t>O objetivo não é
-ter mais processos.</a:t>
+              <a:t>The goal is not
+to have more processes.</a:t>
             </a:r>
           </a:p>
         </p:txBody>
@@ -7142,8 +7142,8 @@
                 </a:solidFill>
                 <a:latin typeface="Titillium Web"/>
               </a:rPr>
-              <a:t>É garantir que cada merchant que merece
-uma demo de nível SE, receba uma.</a:t>
+              <a:t>It's to ensure every merchant who deserves
+an SE-level demo, gets one.</a:t>
             </a:r>
           </a:p>
         </p:txBody>
@@ -7178,7 +7178,7 @@
                 </a:solidFill>
                 <a:latin typeface="Titillium Web"/>
               </a:rPr>
-              <a:t>Solutions Engineering @ Yuno  —  Abril 2026</a:t>
+              <a:t>Solutions Engineering @ Yuno  —  April 2026</a:t>
             </a:r>
           </a:p>
         </p:txBody>
@@ -7387,7 +7387,7 @@
                 </a:solidFill>
                 <a:latin typeface="Titillium Web"/>
               </a:rPr>
-              <a:t>PARTE 01</a:t>
+              <a:t>PART 01</a:t>
             </a:r>
           </a:p>
         </p:txBody>
@@ -7422,8 +7422,8 @@
                 </a:solidFill>
                 <a:latin typeface="Titillium Web"/>
               </a:rPr>
-              <a:t>A Esteira
-Atual</a:t>
+              <a:t>Current
+Process</a:t>
             </a:r>
           </a:p>
         </p:txBody>
@@ -7501,7 +7501,7 @@
                 </a:solidFill>
                 <a:latin typeface="Titillium Web"/>
               </a:rPr>
-              <a:t>Como funciona hoje — e onde estão os gaps.</a:t>
+              <a:t>How it works today — and where the gaps are.</a:t>
             </a:r>
           </a:p>
         </p:txBody>
@@ -7675,7 +7675,7 @@
                 </a:solidFill>
                 <a:latin typeface="Titillium Web"/>
               </a:rPr>
-              <a:t>AS-IS  —  ESTEIRA DE PRÉ-VENDA</a:t>
+              <a:t>AS-IS  —  PRE-SALES PROCESS</a:t>
             </a:r>
           </a:p>
         </p:txBody>
@@ -7710,7 +7710,7 @@
                 </a:solidFill>
                 <a:latin typeface="Titillium Web"/>
               </a:rPr>
-              <a:t>5 etapas. O SE é acionado sem critério.</a:t>
+              <a:t>5 stages. SE is engaged without clear criteria.</a:t>
             </a:r>
           </a:p>
         </p:txBody>
@@ -8628,7 +8628,7 @@
                 </a:solidFill>
                 <a:latin typeface="Titillium Web"/>
               </a:rPr>
-              <a:t>⚠ Sem critério</a:t>
+              <a:t>⚠ No criteria</a:t>
             </a:r>
           </a:p>
         </p:txBody>
@@ -8784,7 +8784,7 @@
                 </a:solidFill>
                 <a:latin typeface="Titillium Web"/>
               </a:rPr>
-              <a:t>Sem critério de acionamento</a:t>
+              <a:t>No SE engagement criteria</a:t>
             </a:r>
           </a:p>
         </p:txBody>
@@ -8819,7 +8819,7 @@
                 </a:solidFill>
                 <a:latin typeface="Titillium Web"/>
               </a:rPr>
-              <a:t>Não há regra sobre quando ou para qual cliente chamar o SE.</a:t>
+              <a:t>No clear rule on when or for which client to engage the SE.</a:t>
             </a:r>
           </a:p>
         </p:txBody>
@@ -8889,7 +8889,7 @@
                 </a:solidFill>
                 <a:latin typeface="Titillium Web"/>
               </a:rPr>
-              <a:t>Sem definição de demo</a:t>
+              <a:t>No demo standard</a:t>
             </a:r>
           </a:p>
         </p:txBody>
@@ -8924,7 +8924,7 @@
                 </a:solidFill>
                 <a:latin typeface="Titillium Web"/>
               </a:rPr>
-              <a:t>Qualidade varia por BDM. Sem padrão mínimo estabelecido.</a:t>
+              <a:t>Quality varies by BDM. No minimum standard defined.</a:t>
             </a:r>
           </a:p>
         </p:txBody>
@@ -8994,7 +8994,7 @@
                 </a:solidFill>
                 <a:latin typeface="Titillium Web"/>
               </a:rPr>
-              <a:t>Discovery incompleto</a:t>
+              <a:t>Incomplete Discovery</a:t>
             </a:r>
           </a:p>
         </p:txBody>
@@ -9029,7 +9029,7 @@
                 </a:solidFill>
                 <a:latin typeface="Titillium Web"/>
               </a:rPr>
-              <a:t>SE entra sem contexto das dores reais. Demo genérica.</a:t>
+              <a:t>SE enters without context on real pain points. Generic demo.</a:t>
             </a:r>
           </a:p>
         </p:txBody>
@@ -9238,7 +9238,7 @@
                 </a:solidFill>
                 <a:latin typeface="Titillium Web"/>
               </a:rPr>
-              <a:t>Três perguntas sem resposta.</a:t>
+              <a:t>Three unanswered questions.</a:t>
             </a:r>
           </a:p>
         </p:txBody>
@@ -9351,7 +9351,7 @@
                 </a:solidFill>
                 <a:latin typeface="Titillium Web"/>
               </a:rPr>
-              <a:t>Quando acionar o SE?</a:t>
+              <a:t>When to engage the SE?</a:t>
             </a:r>
           </a:p>
         </p:txBody>
@@ -9429,7 +9429,7 @@
                 </a:solidFill>
                 <a:latin typeface="Titillium Web"/>
               </a:rPr>
-              <a:t>— Sem critério de $ de contrato mínimo</a:t>
+              <a:t>— No minimum contract $ threshold</a:t>
             </a:r>
           </a:p>
         </p:txBody>
@@ -9464,7 +9464,7 @@
                 </a:solidFill>
                 <a:latin typeface="Titillium Web"/>
               </a:rPr>
-              <a:t>— Sem critério de tamanho / tier do merchant</a:t>
+              <a:t>— No merchant size / tier criteria</a:t>
             </a:r>
           </a:p>
         </p:txBody>
@@ -9499,7 +9499,7 @@
                 </a:solidFill>
                 <a:latin typeface="Titillium Web"/>
               </a:rPr>
-              <a:t>— Sem critério de relevância estratégica</a:t>
+              <a:t>— No strategic relevance criteria</a:t>
             </a:r>
           </a:p>
         </p:txBody>
@@ -9534,7 +9534,7 @@
                 </a:solidFill>
                 <a:latin typeface="Titillium Web"/>
               </a:rPr>
-              <a:t>— Resultado: SE acionado ad hoc, tarde demais</a:t>
+              <a:t>— Result: SE engaged ad hoc, too late</a:t>
             </a:r>
           </a:p>
         </p:txBody>
@@ -9604,7 +9604,7 @@
                 </a:solidFill>
                 <a:latin typeface="Titillium Web"/>
               </a:rPr>
-              <a:t>O que é uma boa demo?</a:t>
+              <a:t>What makes a good demo?</a:t>
             </a:r>
           </a:p>
         </p:txBody>
@@ -9682,7 +9682,7 @@
                 </a:solidFill>
                 <a:latin typeface="Titillium Web"/>
               </a:rPr>
-              <a:t>— Não existe definição interna</a:t>
+              <a:t>— No internal definition exists</a:t>
             </a:r>
           </a:p>
         </p:txBody>
@@ -9717,7 +9717,7 @@
                 </a:solidFill>
                 <a:latin typeface="Titillium Web"/>
               </a:rPr>
-              <a:t>— Qualidade é individual, não do time</a:t>
+              <a:t>— Quality is individual, not team-wide</a:t>
             </a:r>
           </a:p>
         </p:txBody>
@@ -9752,7 +9752,7 @@
                 </a:solidFill>
                 <a:latin typeface="Titillium Web"/>
               </a:rPr>
-              <a:t>— Varia de walkthrough a demos como Cinépolis</a:t>
+              <a:t>— Ranges from generic walkthrough to Cinépolis-level</a:t>
             </a:r>
           </a:p>
         </p:txBody>
@@ -9787,7 +9787,7 @@
                 </a:solidFill>
                 <a:latin typeface="Titillium Web"/>
               </a:rPr>
-              <a:t>— Resultado: percepção inconsistente da Yuno</a:t>
+              <a:t>— Result: inconsistent perception of Yuno</a:t>
             </a:r>
           </a:p>
         </p:txBody>
@@ -9857,7 +9857,7 @@
                 </a:solidFill>
                 <a:latin typeface="Titillium Web"/>
               </a:rPr>
-              <a:t>Como o SE recebe contexto?</a:t>
+              <a:t>How does the SE receive context?</a:t>
             </a:r>
           </a:p>
         </p:txBody>
@@ -9935,7 +9935,7 @@
                 </a:solidFill>
                 <a:latin typeface="Titillium Web"/>
               </a:rPr>
-              <a:t>— Sem documento de Discovery padronizado</a:t>
+              <a:t>— No standardized Discovery document</a:t>
             </a:r>
           </a:p>
         </p:txBody>
@@ -9970,7 +9970,7 @@
                 </a:solidFill>
                 <a:latin typeface="Titillium Web"/>
               </a:rPr>
-              <a:t>— SE desconhece: vertical, volume, stack técnico</a:t>
+              <a:t>— SE doesn't know: vertical, volume, tech stack</a:t>
             </a:r>
           </a:p>
         </p:txBody>
@@ -10005,7 +10005,7 @@
                 </a:solidFill>
                 <a:latin typeface="Titillium Web"/>
               </a:rPr>
-              <a:t>— Pain points não mapeados antes da demo</a:t>
+              <a:t>— Pain points not mapped before the demo</a:t>
             </a:r>
           </a:p>
         </p:txBody>
@@ -10040,7 +10040,7 @@
                 </a:solidFill>
                 <a:latin typeface="Titillium Web"/>
               </a:rPr>
-              <a:t>— Resultado: demos genéricas, sem impacto</a:t>
+              <a:t>— Result: generic demos with no impact</a:t>
             </a:r>
           </a:p>
         </p:txBody>
@@ -10249,7 +10249,7 @@
                 </a:solidFill>
                 <a:latin typeface="Titillium Web"/>
               </a:rPr>
-              <a:t>PARTE 02</a:t>
+              <a:t>PART 02</a:t>
             </a:r>
           </a:p>
         </p:txBody>
@@ -10284,8 +10284,8 @@
                 </a:solidFill>
                 <a:latin typeface="Titillium Web"/>
               </a:rPr>
-              <a:t>A Nova
-Visão</a:t>
+              <a:t>The New
+Vision</a:t>
             </a:r>
           </a:p>
         </p:txBody>
@@ -10363,7 +10363,7 @@
                 </a:solidFill>
                 <a:latin typeface="Titillium Web"/>
               </a:rPr>
-              <a:t>Critérios claros. Handoff estruturado. Demo padrão.</a:t>
+              <a:t>Clear criteria. Structured handoff. Standard demo.</a:t>
             </a:r>
           </a:p>
         </p:txBody>
@@ -10537,7 +10537,7 @@
                 </a:solidFill>
                 <a:latin typeface="Titillium Web"/>
               </a:rPr>
-              <a:t>TO-BE  —  NOVA ESTEIRA DE PRÉ-VENDA</a:t>
+              <a:t>TO-BE  —  NEW PRE-SALES PROCESS</a:t>
             </a:r>
           </a:p>
         </p:txBody>
@@ -10572,7 +10572,7 @@
                 </a:solidFill>
                 <a:latin typeface="Titillium Web"/>
               </a:rPr>
-              <a:t>6 etapas. SE entra com critério e contexto.</a:t>
+              <a:t>6 stages. SE enters with criteria and context.</a:t>
             </a:r>
           </a:p>
         </p:txBody>
@@ -10925,7 +10925,7 @@
                 <a:latin typeface="Titillium Web"/>
               </a:rPr>
               <a:t>Discovery
-(Completo)</a:t>
+(Complete)</a:t>
             </a:r>
           </a:p>
         </p:txBody>
@@ -11040,7 +11040,7 @@
                 </a:solidFill>
                 <a:latin typeface="Titillium Web"/>
               </a:rPr>
-              <a:t>✓ Critério acionado</a:t>
+              <a:t>✓ Criteria met</a:t>
             </a:r>
           </a:p>
         </p:txBody>
@@ -11156,7 +11156,7 @@
                 <a:latin typeface="Titillium Web"/>
               </a:rPr>
               <a:t>Demo
-(Padrão SE)</a:t>
+(SE Standard)</a:t>
             </a:r>
           </a:p>
         </p:txBody>
@@ -11492,7 +11492,7 @@
                 </a:solidFill>
                 <a:latin typeface="Titillium Web"/>
               </a:rPr>
-              <a:t>SE + Time Técnico</a:t>
+              <a:t>SE + Tech Team</a:t>
             </a:r>
           </a:p>
         </p:txBody>
@@ -11572,7 +11572,7 @@
                 </a:solidFill>
                 <a:latin typeface="Titillium Web"/>
               </a:rPr>
-              <a:t>✓ Escopo fechado</a:t>
+              <a:t>✓ Scope defined</a:t>
             </a:r>
           </a:p>
         </p:txBody>
@@ -11878,7 +11878,7 @@
                 </a:solidFill>
                 <a:latin typeface="Titillium Web"/>
               </a:rPr>
-              <a:t>Critério claro de acionamento</a:t>
+              <a:t>Clear engagement criteria</a:t>
             </a:r>
           </a:p>
         </p:txBody>
@@ -11948,7 +11948,7 @@
                 </a:solidFill>
                 <a:latin typeface="Titillium Web"/>
               </a:rPr>
-              <a:t>Discovery completo antes da demo</a:t>
+              <a:t>Complete Discovery before demo</a:t>
             </a:r>
           </a:p>
         </p:txBody>
@@ -12018,7 +12018,7 @@
                 </a:solidFill>
                 <a:latin typeface="Titillium Web"/>
               </a:rPr>
-              <a:t>Technical Scoping antes do contrato</a:t>
+              <a:t>Technical Scoping before contract</a:t>
             </a:r>
           </a:p>
         </p:txBody>
@@ -12088,7 +12088,7 @@
                 </a:solidFill>
                 <a:latin typeface="Titillium Web"/>
               </a:rPr>
-              <a:t>Demo sempre no padrão Cinépolis</a:t>
+              <a:t>Demo always at Cinépolis standard</a:t>
             </a:r>
           </a:p>
         </p:txBody>
@@ -12262,7 +12262,7 @@
                 </a:solidFill>
                 <a:latin typeface="Titillium Web"/>
               </a:rPr>
-              <a:t>TO-BE — CRITÉRIOS DE ACIONAMENTO</a:t>
+              <a:t>TO-BE — SE ENGAGEMENT CRITERIA</a:t>
             </a:r>
           </a:p>
         </p:txBody>
@@ -12297,8 +12297,8 @@
                 </a:solidFill>
                 <a:latin typeface="Titillium Web"/>
               </a:rPr>
-              <a:t>SE é acionado quando o deal
-atende pelo menos um critério.</a:t>
+              <a:t>SE is engaged when the deal
+meets at least one criterion.</a:t>
             </a:r>
           </a:p>
         </p:txBody>
@@ -12585,7 +12585,7 @@
                 </a:solidFill>
                 <a:latin typeface="Titillium Web"/>
               </a:rPr>
-              <a:t>Valor de Contrato</a:t>
+              <a:t>Contract Value</a:t>
             </a:r>
           </a:p>
         </p:txBody>
@@ -12620,7 +12620,7 @@
                 </a:solidFill>
                 <a:latin typeface="Titillium Web"/>
               </a:rPr>
-              <a:t>TAR acima do threshold definido — ex.: &gt; $50k anuais</a:t>
+              <a:t>TAR above defined threshold — e.g.: &gt; $50k annually</a:t>
             </a:r>
           </a:p>
         </p:txBody>
@@ -12698,7 +12698,7 @@
                 </a:solidFill>
                 <a:latin typeface="Titillium Web"/>
               </a:rPr>
-              <a:t>Deals menores seguem fluxo simplificado.</a:t>
+              <a:t>Smaller deals follow a simplified flow without SE.</a:t>
             </a:r>
           </a:p>
         </p:txBody>
@@ -12942,7 +12942,7 @@
                 </a:solidFill>
                 <a:latin typeface="Titillium Web"/>
               </a:rPr>
-              <a:t>Tamanho do Merchant</a:t>
+              <a:t>Merchant Size</a:t>
             </a:r>
           </a:p>
         </p:txBody>
@@ -12977,7 +12977,7 @@
                 </a:solidFill>
                 <a:latin typeface="Titillium Web"/>
               </a:rPr>
-              <a:t>Enterprise ou Mid-Market com equipe técnica interna</a:t>
+              <a:t>Enterprise or Mid-Market with internal technical team</a:t>
             </a:r>
           </a:p>
         </p:txBody>
@@ -13055,7 +13055,7 @@
                 </a:solidFill>
                 <a:latin typeface="Titillium Web"/>
               </a:rPr>
-              <a:t>Contas pequenas com integração simples não acionam SE.</a:t>
+              <a:t>Small accounts with simple integration don't trigger SE.</a:t>
             </a:r>
           </a:p>
         </p:txBody>
@@ -13299,7 +13299,7 @@
                 </a:solidFill>
                 <a:latin typeface="Titillium Web"/>
               </a:rPr>
-              <a:t>Conta Estratégica</a:t>
+              <a:t>Strategic Account</a:t>
             </a:r>
           </a:p>
         </p:txBody>
@@ -13334,7 +13334,7 @@
                 </a:solidFill>
                 <a:latin typeface="Titillium Web"/>
               </a:rPr>
-              <a:t>Vertical prioritária: fintech, e-commerce, governo</a:t>
+              <a:t>Priority vertical: fintech, e-commerce, government</a:t>
             </a:r>
           </a:p>
         </p:txBody>
@@ -13412,7 +13412,7 @@
                 </a:solidFill>
                 <a:latin typeface="Titillium Web"/>
               </a:rPr>
-              <a:t>Qualquer deal marcado 'strategic' pelo head comercial.</a:t>
+              <a:t>Any deal flagged as 'strategic' by the commercial head.</a:t>
             </a:r>
           </a:p>
         </p:txBody>
@@ -13656,7 +13656,7 @@
                 </a:solidFill>
                 <a:latin typeface="Titillium Web"/>
               </a:rPr>
-              <a:t>Complexidade Técnica</a:t>
+              <a:t>Technical Complexity</a:t>
             </a:r>
           </a:p>
         </p:txBody>
@@ -13691,7 +13691,7 @@
                 </a:solidFill>
                 <a:latin typeface="Titillium Web"/>
               </a:rPr>
-              <a:t>Stack customizado, múltiplos métodos, 3DS, orquestração</a:t>
+              <a:t>Custom stack, multiple methods, 3DS, orchestration</a:t>
             </a:r>
           </a:p>
         </p:txBody>
@@ -13769,7 +13769,7 @@
                 </a:solidFill>
                 <a:latin typeface="Titillium Web"/>
               </a:rPr>
-              <a:t>BDM registra dúvida técnica no Discovery ticket → SE avalia: reunião ou resposta async.</a:t>
+              <a:t>BDM logs the technical question in the Discovery ticket → SE evaluates: meeting needed or can respond async.</a:t>
             </a:r>
           </a:p>
         </p:txBody>
@@ -14064,8 +14064,8 @@
                 </a:solidFill>
                 <a:latin typeface="Titillium Web"/>
               </a:rPr>
-              <a:t>Ticket de
-Discovery</a:t>
+              <a:t>Discovery
+Ticket</a:t>
             </a:r>
           </a:p>
         </p:txBody>
@@ -14256,7 +14256,7 @@
                 </a:solidFill>
                 <a:latin typeface="Titillium Web"/>
               </a:rPr>
-              <a:t>BDM qualifica o deal</a:t>
+              <a:t>BDM qualifies the deal</a:t>
             </a:r>
           </a:p>
         </p:txBody>
@@ -14369,7 +14369,7 @@
                 </a:solidFill>
                 <a:latin typeface="Titillium Web"/>
               </a:rPr>
-              <a:t>Preenche Discovery doc</a:t>
+              <a:t>Fills out Discovery doc</a:t>
             </a:r>
           </a:p>
         </p:txBody>
@@ -14482,7 +14482,7 @@
                 </a:solidFill>
                 <a:latin typeface="Titillium Web"/>
               </a:rPr>
-              <a:t>Abre ticket + prazo</a:t>
+              <a:t>Opens ticket + desired timeline</a:t>
             </a:r>
           </a:p>
         </p:txBody>
@@ -14595,7 +14595,7 @@
                 </a:solidFill>
                 <a:latin typeface="Titillium Web"/>
               </a:rPr>
-              <a:t>SE confirma SLA (48h)</a:t>
+              <a:t>SE confirms SLA (48h)</a:t>
             </a:r>
           </a:p>
         </p:txBody>
@@ -14708,7 +14708,7 @@
                 </a:solidFill>
                 <a:latin typeface="Titillium Web"/>
               </a:rPr>
-              <a:t>SE prepara demo</a:t>
+              <a:t>SE prepares the demo</a:t>
             </a:r>
           </a:p>
         </p:txBody>
@@ -14743,7 +14743,7 @@
                 </a:solidFill>
                 <a:latin typeface="Titillium Web"/>
               </a:rPr>
-              <a:t>CAMPOS OBRIGATÓRIOS</a:t>
+              <a:t>REQUIRED FIELDS</a:t>
             </a:r>
           </a:p>
         </p:txBody>
@@ -14778,8 +14778,8 @@
                 </a:solidFill>
                 <a:latin typeface="Titillium Web"/>
               </a:rPr>
-              <a:t>O SE não avança
-sem o documento completo.</a:t>
+              <a:t>SE does not proceed
+without the complete document.</a:t>
             </a:r>
           </a:p>
         </p:txBody>
@@ -14937,7 +14937,7 @@
                 </a:solidFill>
                 <a:latin typeface="Titillium Web"/>
               </a:rPr>
-              <a:t>Nome, site, vertical, país de operação</a:t>
+              <a:t>Name, website, vertical, country of operation</a:t>
             </a:r>
           </a:p>
         </p:txBody>
@@ -15060,7 +15060,7 @@
                 </a:solidFill>
                 <a:latin typeface="Titillium Web"/>
               </a:rPr>
-              <a:t>Contato técnico</a:t>
+              <a:t>Technical contact</a:t>
             </a:r>
           </a:p>
         </p:txBody>
@@ -15095,7 +15095,7 @@
                 </a:solidFill>
                 <a:latin typeface="Titillium Web"/>
               </a:rPr>
-              <a:t>Time de dev interno? Stack utilizado?</a:t>
+              <a:t>Internal dev team? Tech stack used?</a:t>
             </a:r>
           </a:p>
         </p:txBody>
@@ -15218,7 +15218,7 @@
                 </a:solidFill>
                 <a:latin typeface="Titillium Web"/>
               </a:rPr>
-              <a:t>Volume estimado</a:t>
+              <a:t>Estimated volume</a:t>
             </a:r>
           </a:p>
         </p:txBody>
@@ -15253,7 +15253,7 @@
                 </a:solidFill>
                 <a:latin typeface="Titillium Web"/>
               </a:rPr>
-              <a:t>Transações/mês, ticket médio, moedas</a:t>
+              <a:t>Transactions/month, average ticket, currencies</a:t>
             </a:r>
           </a:p>
         </p:txBody>
@@ -15376,7 +15376,7 @@
                 </a:solidFill>
                 <a:latin typeface="Titillium Web"/>
               </a:rPr>
-              <a:t>Métodos</a:t>
+              <a:t>Payment methods</a:t>
             </a:r>
           </a:p>
         </p:txBody>
@@ -15411,7 +15411,7 @@
                 </a:solidFill>
                 <a:latin typeface="Titillium Web"/>
               </a:rPr>
-              <a:t>Quais usa hoje? O que quer adicionar?</a:t>
+              <a:t>Which ones today? What do they want to add?</a:t>
             </a:r>
           </a:p>
         </p:txBody>
@@ -15569,7 +15569,7 @@
                 </a:solidFill>
                 <a:latin typeface="Titillium Web"/>
               </a:rPr>
-              <a:t>Por que buscam o Yuno? O que falha?</a:t>
+              <a:t>Why are they looking at Yuno? What's failing?</a:t>
             </a:r>
           </a:p>
         </p:txBody>
@@ -15692,7 +15692,7 @@
                 </a:solidFill>
                 <a:latin typeface="Titillium Web"/>
               </a:rPr>
-              <a:t>Jornada do pagador</a:t>
+              <a:t>Payer journey</a:t>
             </a:r>
           </a:p>
         </p:txBody>
@@ -15727,7 +15727,7 @@
                 </a:solidFill>
                 <a:latin typeface="Titillium Web"/>
               </a:rPr>
-              <a:t>App, web, in-person? Como é o checkout?</a:t>
+              <a:t>App, web, in-person? What does checkout look like?</a:t>
             </a:r>
           </a:p>
         </p:txBody>
@@ -15850,7 +15850,7 @@
                 </a:solidFill>
                 <a:latin typeface="Titillium Web"/>
               </a:rPr>
-              <a:t>Decisores</a:t>
+              <a:t>Decision makers</a:t>
             </a:r>
           </a:p>
         </p:txBody>
@@ -15885,7 +15885,7 @@
                 </a:solidFill>
                 <a:latin typeface="Titillium Web"/>
               </a:rPr>
-              <a:t>CTO, CEO, Head de Produto na reunião?</a:t>
+              <a:t>CTO, CEO, Head of Product in the room?</a:t>
             </a:r>
           </a:p>
         </p:txBody>
@@ -16043,7 +16043,7 @@
                 </a:solidFill>
                 <a:latin typeface="Titillium Web"/>
               </a:rPr>
-              <a:t>Go-live desejado? Datas críticas?</a:t>
+              <a:t>Desired go-live? Critical dates?</a:t>
             </a:r>
           </a:p>
         </p:txBody>
@@ -16260,7 +16260,7 @@
                 </a:solidFill>
                 <a:latin typeface="Titillium Web"/>
               </a:rPr>
-              <a:t>TO-BE — PADRÃO DE DEMO</a:t>
+              <a:t>TO-BE — DEMO STANDARD</a:t>
             </a:r>
           </a:p>
         </p:txBody>
@@ -16295,7 +16295,7 @@
                 </a:solidFill>
                 <a:latin typeface="Titillium Web"/>
               </a:rPr>
-              <a:t>Referência interna: a demo da Cinépolis.</a:t>
+              <a:t>Internal benchmark: the Cinépolis demo.</a:t>
             </a:r>
           </a:p>
         </p:txBody>
@@ -16459,7 +16459,7 @@
                 </a:solidFill>
                 <a:latin typeface="Titillium Web"/>
               </a:rPr>
-              <a:t>NÃO ACEITÁVEL</a:t>
+              <a:t>NOT ACCEPTABLE</a:t>
             </a:r>
           </a:p>
         </p:txBody>
@@ -16494,7 +16494,7 @@
                 </a:solidFill>
                 <a:latin typeface="Titillium Web"/>
               </a:rPr>
-              <a:t>✕  Tour genérico pelo dashboard sem contexto</a:t>
+              <a:t>✕  Generic dashboard tour with no merchant context</a:t>
             </a:r>
           </a:p>
         </p:txBody>
@@ -16529,7 +16529,7 @@
                 </a:solidFill>
                 <a:latin typeface="Titillium Web"/>
               </a:rPr>
-              <a:t>✕  Demo ao vivo na sandbox sem personalização</a:t>
+              <a:t>✕  Live sandbox demo with zero customization</a:t>
             </a:r>
           </a:p>
         </p:txBody>
@@ -16564,7 +16564,7 @@
                 </a:solidFill>
                 <a:latin typeface="Titillium Web"/>
               </a:rPr>
-              <a:t>✕  Features que o merchant não vai usar</a:t>
+              <a:t>✕  Features the merchant won't use</a:t>
             </a:r>
           </a:p>
         </p:txBody>
@@ -16599,7 +16599,7 @@
                 </a:solidFill>
                 <a:latin typeface="Titillium Web"/>
               </a:rPr>
-              <a:t>✕  SE não sabe o vertical nem os pain points</a:t>
+              <a:t>✕  SE doesn't know the vertical or pain points</a:t>
             </a:r>
           </a:p>
         </p:txBody>
@@ -16634,7 +16634,7 @@
                 </a:solidFill>
                 <a:latin typeface="Titillium Web"/>
               </a:rPr>
-              <a:t>✕  Sem demonstrar a jornada do pagador</a:t>
+              <a:t>✕  No payer journey shown</a:t>
             </a:r>
           </a:p>
         </p:txBody>
@@ -16669,7 +16669,7 @@
                 </a:solidFill>
                 <a:latin typeface="Titillium Web"/>
               </a:rPr>
-              <a:t>✕  Apenas UI — nenhuma integração técnica</a:t>
+              <a:t>✕  UI only — no technical integration shown</a:t>
             </a:r>
           </a:p>
         </p:txBody>
@@ -16825,7 +16825,7 @@
                 </a:solidFill>
                 <a:latin typeface="Titillium Web"/>
               </a:rPr>
-              <a:t>PADRÃO SE (CINÉPOLIS)</a:t>
+              <a:t>SE STANDARD (CINÉPOLIS)</a:t>
             </a:r>
           </a:p>
         </p:txBody>
@@ -16860,7 +16860,7 @@
                 </a:solidFill>
                 <a:latin typeface="Titillium Web"/>
               </a:rPr>
-              <a:t>✓  Dores mapeadas no Discovery antes da demo</a:t>
+              <a:t>✓  Pain points mapped in Discovery before the demo</a:t>
             </a:r>
           </a:p>
         </p:txBody>
@@ -16895,7 +16895,7 @@
                 </a:solidFill>
                 <a:latin typeface="Titillium Web"/>
               </a:rPr>
-              <a:t>✓  Jornada do pagador customizada ao vertical</a:t>
+              <a:t>✓  Payer journey customized to the merchant's vertical</a:t>
             </a:r>
           </a:p>
         </p:txBody>
@@ -16930,7 +16930,7 @@
                 </a:solidFill>
                 <a:latin typeface="Titillium Web"/>
               </a:rPr>
-              <a:t>✓  Integração técnica demonstrada: SDK / API</a:t>
+              <a:t>✓  Technical integration demonstrated: SDK / API</a:t>
             </a:r>
           </a:p>
         </p:txBody>
@@ -16965,7 +16965,7 @@
                 </a:solidFill>
                 <a:latin typeface="Titillium Web"/>
               </a:rPr>
-              <a:t>✓  Métodos relevantes para o país do merchant</a:t>
+              <a:t>✓  Payment methods relevant to the merchant's country</a:t>
             </a:r>
           </a:p>
         </p:txBody>
@@ -17000,7 +17000,7 @@
                 </a:solidFill>
                 <a:latin typeface="Titillium Web"/>
               </a:rPr>
-              <a:t>✓  3DS, fallback, orquestração se aplicável</a:t>
+              <a:t>✓  3DS, fallback, orchestration when applicable</a:t>
             </a:r>
           </a:p>
         </p:txBody>
@@ -17035,7 +17035,7 @@
                 </a:solidFill>
                 <a:latin typeface="Titillium Web"/>
               </a:rPr>
-              <a:t>✓  Linguagem do merchant — não de TI</a:t>
+              <a:t>✓  Merchant's language — not IT jargon</a:t>
             </a:r>
           </a:p>
         </p:txBody>

</xml_diff>